<commit_message>
update experiment results table
</commit_message>
<xml_diff>
--- a/documents/MelisoFramework_GT.pptx
+++ b/documents/MelisoFramework_GT.pptx
@@ -10,8 +10,7 @@
     <p:sldId id="259" r:id="rId4"/>
     <p:sldId id="263" r:id="rId5"/>
     <p:sldId id="260" r:id="rId6"/>
-    <p:sldId id="262" r:id="rId7"/>
-    <p:sldId id="261" r:id="rId8"/>
+    <p:sldId id="261" r:id="rId7"/>
   </p:sldIdLst>
   <p:sldSz cx="18288000" cy="10972800"/>
   <p:notesSz cx="6858000" cy="9144000"/>
@@ -141,8 +140,8 @@
 <pc:chgInfo xmlns:a="http://schemas.openxmlformats.org/drawingml/2006/main" xmlns:r="http://schemas.openxmlformats.org/officeDocument/2006/relationships" xmlns:ac="http://schemas.microsoft.com/office/drawing/2013/main/command" xmlns:pc="http://schemas.microsoft.com/office/powerpoint/2013/main/command">
   <pc:docChgLst>
     <pc:chgData name="Quang-Nguyen Vo-Huynh" userId="6a1b2bcfbbb34c0c" providerId="LiveId" clId="{418D35BF-17D0-47EF-B050-F7703380D9D6}"/>
-    <pc:docChg chg="undo custSel addSld modSld sldOrd">
-      <pc:chgData name="Quang-Nguyen Vo-Huynh" userId="6a1b2bcfbbb34c0c" providerId="LiveId" clId="{418D35BF-17D0-47EF-B050-F7703380D9D6}" dt="2024-09-20T00:14:18.288" v="309" actId="14100"/>
+    <pc:docChg chg="undo custSel addSld delSld modSld sldOrd">
+      <pc:chgData name="Quang-Nguyen Vo-Huynh" userId="6a1b2bcfbbb34c0c" providerId="LiveId" clId="{418D35BF-17D0-47EF-B050-F7703380D9D6}" dt="2024-09-23T21:47:25.144" v="310" actId="2696"/>
       <pc:docMkLst>
         <pc:docMk/>
       </pc:docMkLst>
@@ -1765,8 +1764,8 @@
           </ac:picMkLst>
         </pc:picChg>
       </pc:sldChg>
-      <pc:sldChg chg="addSp delSp modSp new mod">
-        <pc:chgData name="Quang-Nguyen Vo-Huynh" userId="6a1b2bcfbbb34c0c" providerId="LiveId" clId="{418D35BF-17D0-47EF-B050-F7703380D9D6}" dt="2024-09-20T00:12:44.535" v="285" actId="478"/>
+      <pc:sldChg chg="addSp delSp modSp new del mod">
+        <pc:chgData name="Quang-Nguyen Vo-Huynh" userId="6a1b2bcfbbb34c0c" providerId="LiveId" clId="{418D35BF-17D0-47EF-B050-F7703380D9D6}" dt="2024-09-23T21:47:25.144" v="310" actId="2696"/>
         <pc:sldMkLst>
           <pc:docMk/>
           <pc:sldMk cId="772875685" sldId="262"/>
@@ -2083,7 +2082,7 @@
           <a:p>
             <a:fld id="{F59C06B4-8593-4EB8-B79F-B0D577D596E5}" type="datetimeFigureOut">
               <a:rPr lang="en-US" smtClean="0"/>
-              <a:t>9/19/24</a:t>
+              <a:t>9/23/2024</a:t>
             </a:fld>
             <a:endParaRPr lang="en-US"/>
           </a:p>
@@ -2253,7 +2252,7 @@
           <a:p>
             <a:fld id="{F59C06B4-8593-4EB8-B79F-B0D577D596E5}" type="datetimeFigureOut">
               <a:rPr lang="en-US" smtClean="0"/>
-              <a:t>9/19/24</a:t>
+              <a:t>9/23/2024</a:t>
             </a:fld>
             <a:endParaRPr lang="en-US"/>
           </a:p>
@@ -2433,7 +2432,7 @@
           <a:p>
             <a:fld id="{F59C06B4-8593-4EB8-B79F-B0D577D596E5}" type="datetimeFigureOut">
               <a:rPr lang="en-US" smtClean="0"/>
-              <a:t>9/19/24</a:t>
+              <a:t>9/23/2024</a:t>
             </a:fld>
             <a:endParaRPr lang="en-US"/>
           </a:p>
@@ -2603,7 +2602,7 @@
           <a:p>
             <a:fld id="{F59C06B4-8593-4EB8-B79F-B0D577D596E5}" type="datetimeFigureOut">
               <a:rPr lang="en-US" smtClean="0"/>
-              <a:t>9/19/24</a:t>
+              <a:t>9/23/2024</a:t>
             </a:fld>
             <a:endParaRPr lang="en-US"/>
           </a:p>
@@ -2849,7 +2848,7 @@
           <a:p>
             <a:fld id="{F59C06B4-8593-4EB8-B79F-B0D577D596E5}" type="datetimeFigureOut">
               <a:rPr lang="en-US" smtClean="0"/>
-              <a:t>9/19/24</a:t>
+              <a:t>9/23/2024</a:t>
             </a:fld>
             <a:endParaRPr lang="en-US"/>
           </a:p>
@@ -3081,7 +3080,7 @@
           <a:p>
             <a:fld id="{F59C06B4-8593-4EB8-B79F-B0D577D596E5}" type="datetimeFigureOut">
               <a:rPr lang="en-US" smtClean="0"/>
-              <a:t>9/19/24</a:t>
+              <a:t>9/23/2024</a:t>
             </a:fld>
             <a:endParaRPr lang="en-US"/>
           </a:p>
@@ -3448,7 +3447,7 @@
           <a:p>
             <a:fld id="{F59C06B4-8593-4EB8-B79F-B0D577D596E5}" type="datetimeFigureOut">
               <a:rPr lang="en-US" smtClean="0"/>
-              <a:t>9/19/24</a:t>
+              <a:t>9/23/2024</a:t>
             </a:fld>
             <a:endParaRPr lang="en-US"/>
           </a:p>
@@ -3566,7 +3565,7 @@
           <a:p>
             <a:fld id="{F59C06B4-8593-4EB8-B79F-B0D577D596E5}" type="datetimeFigureOut">
               <a:rPr lang="en-US" smtClean="0"/>
-              <a:t>9/19/24</a:t>
+              <a:t>9/23/2024</a:t>
             </a:fld>
             <a:endParaRPr lang="en-US"/>
           </a:p>
@@ -3661,7 +3660,7 @@
           <a:p>
             <a:fld id="{F59C06B4-8593-4EB8-B79F-B0D577D596E5}" type="datetimeFigureOut">
               <a:rPr lang="en-US" smtClean="0"/>
-              <a:t>9/19/24</a:t>
+              <a:t>9/23/2024</a:t>
             </a:fld>
             <a:endParaRPr lang="en-US"/>
           </a:p>
@@ -3938,7 +3937,7 @@
           <a:p>
             <a:fld id="{F59C06B4-8593-4EB8-B79F-B0D577D596E5}" type="datetimeFigureOut">
               <a:rPr lang="en-US" smtClean="0"/>
-              <a:t>9/19/24</a:t>
+              <a:t>9/23/2024</a:t>
             </a:fld>
             <a:endParaRPr lang="en-US"/>
           </a:p>
@@ -4195,7 +4194,7 @@
           <a:p>
             <a:fld id="{F59C06B4-8593-4EB8-B79F-B0D577D596E5}" type="datetimeFigureOut">
               <a:rPr lang="en-US" smtClean="0"/>
-              <a:t>9/19/24</a:t>
+              <a:t>9/23/2024</a:t>
             </a:fld>
             <a:endParaRPr lang="en-US"/>
           </a:p>
@@ -4408,7 +4407,7 @@
           <a:p>
             <a:fld id="{F59C06B4-8593-4EB8-B79F-B0D577D596E5}" type="datetimeFigureOut">
               <a:rPr lang="en-US" smtClean="0"/>
-              <a:t>9/19/24</a:t>
+              <a:t>9/23/2024</a:t>
             </a:fld>
             <a:endParaRPr lang="en-US"/>
           </a:p>
@@ -16697,102 +16696,6 @@
 </file>
 
 <file path=ppt/slides/slide6.xml><?xml version="1.0" encoding="utf-8"?>
-<p:sld xmlns:a="http://schemas.openxmlformats.org/drawingml/2006/main" xmlns:r="http://schemas.openxmlformats.org/officeDocument/2006/relationships" xmlns:p="http://schemas.openxmlformats.org/presentationml/2006/main">
-  <p:cSld>
-    <p:spTree>
-      <p:nvGrpSpPr>
-        <p:cNvPr id="1" name=""/>
-        <p:cNvGrpSpPr/>
-        <p:nvPr/>
-      </p:nvGrpSpPr>
-      <p:grpSpPr>
-        <a:xfrm>
-          <a:off x="0" y="0"/>
-          <a:ext cx="0" cy="0"/>
-          <a:chOff x="0" y="0"/>
-          <a:chExt cx="0" cy="0"/>
-        </a:xfrm>
-      </p:grpSpPr>
-      <p:sp>
-        <p:nvSpPr>
-          <p:cNvPr id="4" name="TextBox 3">
-            <a:extLst>
-              <a:ext uri="{FF2B5EF4-FFF2-40B4-BE49-F238E27FC236}">
-                <a16:creationId xmlns:a16="http://schemas.microsoft.com/office/drawing/2014/main" id="{AC91A7D4-5460-FE2E-2261-FA219A93EBDE}"/>
-              </a:ext>
-            </a:extLst>
-          </p:cNvPr>
-          <p:cNvSpPr txBox="1"/>
-          <p:nvPr/>
-        </p:nvSpPr>
-        <p:spPr>
-          <a:xfrm flipH="1">
-            <a:off x="2295431" y="286748"/>
-            <a:ext cx="1550853" cy="369332"/>
-          </a:xfrm>
-          <a:prstGeom prst="rect">
-            <a:avLst/>
-          </a:prstGeom>
-          <a:noFill/>
-        </p:spPr>
-        <p:txBody>
-          <a:bodyPr wrap="square" rtlCol="0">
-            <a:spAutoFit/>
-          </a:bodyPr>
-          <a:lstStyle/>
-          <a:p>
-            <a:r>
-              <a:rPr lang="en-US" dirty="0" err="1"/>
-              <a:t>TaOx-HfOx</a:t>
-            </a:r>
-            <a:endParaRPr lang="en-US" dirty="0"/>
-          </a:p>
-        </p:txBody>
-      </p:sp>
-      <p:pic>
-        <p:nvPicPr>
-          <p:cNvPr id="13" name="Picture 12">
-            <a:extLst>
-              <a:ext uri="{FF2B5EF4-FFF2-40B4-BE49-F238E27FC236}">
-                <a16:creationId xmlns:a16="http://schemas.microsoft.com/office/drawing/2014/main" id="{1BC2B800-D8AF-640E-578A-916BCD3D5393}"/>
-              </a:ext>
-            </a:extLst>
-          </p:cNvPr>
-          <p:cNvPicPr>
-            <a:picLocks noChangeAspect="1"/>
-          </p:cNvPicPr>
-          <p:nvPr/>
-        </p:nvPicPr>
-        <p:blipFill>
-          <a:blip r:embed="rId2"/>
-          <a:stretch>
-            <a:fillRect/>
-          </a:stretch>
-        </p:blipFill>
-        <p:spPr>
-          <a:xfrm>
-            <a:off x="7069828" y="3543538"/>
-            <a:ext cx="6306430" cy="2200582"/>
-          </a:xfrm>
-          <a:prstGeom prst="rect">
-            <a:avLst/>
-          </a:prstGeom>
-        </p:spPr>
-      </p:pic>
-    </p:spTree>
-    <p:extLst>
-      <p:ext uri="{BB962C8B-B14F-4D97-AF65-F5344CB8AC3E}">
-        <p14:creationId xmlns:p14="http://schemas.microsoft.com/office/powerpoint/2010/main" val="772875685"/>
-      </p:ext>
-    </p:extLst>
-  </p:cSld>
-  <p:clrMapOvr>
-    <a:masterClrMapping/>
-  </p:clrMapOvr>
-</p:sld>
-</file>
-
-<file path=ppt/slides/slide7.xml><?xml version="1.0" encoding="utf-8"?>
 <p:sld xmlns:a="http://schemas.openxmlformats.org/drawingml/2006/main" xmlns:r="http://schemas.openxmlformats.org/officeDocument/2006/relationships" xmlns:p="http://schemas.openxmlformats.org/presentationml/2006/main" show="0">
   <p:cSld>
     <p:spTree>

</xml_diff>